<commit_message>
Slides: remove Evaluation Plan slide
Co-Authored-By: Claude Opus 5.5 <noreply@anthropic.com>
</commit_message>
<xml_diff>
--- a/docs/slides/CampusGPT_Major_Project.pptx
+++ b/docs/slides/CampusGPT_Major_Project.pptx
@@ -23,7 +23,6 @@
     <p:sldId id="271" r:id="rId22"/>
     <p:sldId id="272" r:id="rId23"/>
     <p:sldId id="273" r:id="rId24"/>
-    <p:sldId id="274" r:id="rId25"/>
   </p:sldIdLst>
   <p:notesMasterIdLst>
     <p:notesMasterId r:id="rId17"/>
@@ -3176,1145 +3175,7 @@
                   <a:schemeClr val="tx1"/>
                 </a:solidFill>
               </a:rPr>
-              <a:t>13. Evaluation Plan</a:t>
-            </a:r>
-          </a:p>
-        </p:txBody>
-      </p:sp>
-      <p:graphicFrame>
-        <p:nvGraphicFramePr>
-          <p:cNvPr id="3" name="Table 2"/>
-          <p:cNvGraphicFramePr>
-            <a:graphicFrameLocks noGrp="1"/>
-          </p:cNvGraphicFramePr>
-          <p:nvPr/>
-        </p:nvGraphicFramePr>
-        <p:xfrm>
-          <a:off x="384048" y="1051560"/>
-          <a:ext cx="11430000" cy="3200400"/>
-        </p:xfrm>
-        <a:graphic>
-          <a:graphicData uri="http://schemas.openxmlformats.org/drawingml/2006/table">
-            <a:tbl>
-              <a:tblPr firstRow="0" bandRow="0"/>
-              <a:tblGrid>
-                <a:gridCol w="2743200"/>
-                <a:gridCol w="5120640"/>
-                <a:gridCol w="3566160"/>
-              </a:tblGrid>
-              <a:tr h="457200">
-                <a:tc>
-                  <a:txBody>
-                    <a:bodyPr wrap="square"/>
-                    <a:lstStyle/>
-                    <a:p>
-                      <a:r>
-                        <a:rPr sz="1400" b="1" i="0">
-                          <a:solidFill>
-                            <a:schemeClr val="tx1"/>
-                          </a:solidFill>
-                        </a:rPr>
-                        <a:t>Metric</a:t>
-                      </a:r>
-                    </a:p>
-                  </a:txBody>
-                  <a:tcPr marL="91440" marR="91440" marT="36576" marB="36576" anchor="ctr">
-                    <a:lnL w="12700" cap="flat" cmpd="sng" algn="ctr">
-                      <a:solidFill>
-                        <a:schemeClr val="tx1"/>
-                      </a:solidFill>
-                      <a:prstDash val="solid"/>
-                    </a:lnL>
-                    <a:lnR w="12700" cap="flat" cmpd="sng" algn="ctr">
-                      <a:solidFill>
-                        <a:schemeClr val="tx1"/>
-                      </a:solidFill>
-                      <a:prstDash val="solid"/>
-                    </a:lnR>
-                    <a:lnT w="12700" cap="flat" cmpd="sng" algn="ctr">
-                      <a:solidFill>
-                        <a:schemeClr val="tx1"/>
-                      </a:solidFill>
-                      <a:prstDash val="solid"/>
-                    </a:lnT>
-                    <a:lnB w="12700" cap="flat" cmpd="sng" algn="ctr">
-                      <a:solidFill>
-                        <a:schemeClr val="tx1"/>
-                      </a:solidFill>
-                      <a:prstDash val="solid"/>
-                    </a:lnB>
-                    <a:solidFill>
-                      <a:schemeClr val="bg2"/>
-                    </a:solidFill>
-                  </a:tcPr>
-                </a:tc>
-                <a:tc>
-                  <a:txBody>
-                    <a:bodyPr wrap="square"/>
-                    <a:lstStyle/>
-                    <a:p>
-                      <a:r>
-                        <a:rPr sz="1400" b="1" i="0">
-                          <a:solidFill>
-                            <a:schemeClr val="tx1"/>
-                          </a:solidFill>
-                        </a:rPr>
-                        <a:t>How it is measured</a:t>
-                      </a:r>
-                    </a:p>
-                  </a:txBody>
-                  <a:tcPr marL="91440" marR="91440" marT="36576" marB="36576" anchor="ctr">
-                    <a:lnL w="12700" cap="flat" cmpd="sng" algn="ctr">
-                      <a:solidFill>
-                        <a:schemeClr val="tx1"/>
-                      </a:solidFill>
-                      <a:prstDash val="solid"/>
-                    </a:lnL>
-                    <a:lnR w="12700" cap="flat" cmpd="sng" algn="ctr">
-                      <a:solidFill>
-                        <a:schemeClr val="tx1"/>
-                      </a:solidFill>
-                      <a:prstDash val="solid"/>
-                    </a:lnR>
-                    <a:lnT w="12700" cap="flat" cmpd="sng" algn="ctr">
-                      <a:solidFill>
-                        <a:schemeClr val="tx1"/>
-                      </a:solidFill>
-                      <a:prstDash val="solid"/>
-                    </a:lnT>
-                    <a:lnB w="12700" cap="flat" cmpd="sng" algn="ctr">
-                      <a:solidFill>
-                        <a:schemeClr val="tx1"/>
-                      </a:solidFill>
-                      <a:prstDash val="solid"/>
-                    </a:lnB>
-                    <a:solidFill>
-                      <a:schemeClr val="bg2"/>
-                    </a:solidFill>
-                  </a:tcPr>
-                </a:tc>
-                <a:tc>
-                  <a:txBody>
-                    <a:bodyPr wrap="square"/>
-                    <a:lstStyle/>
-                    <a:p>
-                      <a:r>
-                        <a:rPr sz="1400" b="1" i="0">
-                          <a:solidFill>
-                            <a:schemeClr val="tx1"/>
-                          </a:solidFill>
-                        </a:rPr>
-                        <a:t>Target or comparison</a:t>
-                      </a:r>
-                    </a:p>
-                  </a:txBody>
-                  <a:tcPr marL="91440" marR="91440" marT="36576" marB="36576" anchor="ctr">
-                    <a:lnL w="12700" cap="flat" cmpd="sng" algn="ctr">
-                      <a:solidFill>
-                        <a:schemeClr val="tx1"/>
-                      </a:solidFill>
-                      <a:prstDash val="solid"/>
-                    </a:lnL>
-                    <a:lnR w="12700" cap="flat" cmpd="sng" algn="ctr">
-                      <a:solidFill>
-                        <a:schemeClr val="tx1"/>
-                      </a:solidFill>
-                      <a:prstDash val="solid"/>
-                    </a:lnR>
-                    <a:lnT w="12700" cap="flat" cmpd="sng" algn="ctr">
-                      <a:solidFill>
-                        <a:schemeClr val="tx1"/>
-                      </a:solidFill>
-                      <a:prstDash val="solid"/>
-                    </a:lnT>
-                    <a:lnB w="12700" cap="flat" cmpd="sng" algn="ctr">
-                      <a:solidFill>
-                        <a:schemeClr val="tx1"/>
-                      </a:solidFill>
-                      <a:prstDash val="solid"/>
-                    </a:lnB>
-                    <a:solidFill>
-                      <a:schemeClr val="bg2"/>
-                    </a:solidFill>
-                  </a:tcPr>
-                </a:tc>
-              </a:tr>
-              <a:tr h="457200">
-                <a:tc>
-                  <a:txBody>
-                    <a:bodyPr wrap="square"/>
-                    <a:lstStyle/>
-                    <a:p>
-                      <a:r>
-                        <a:rPr sz="1400" b="0" i="0">
-                          <a:solidFill>
-                            <a:schemeClr val="tx1"/>
-                          </a:solidFill>
-                        </a:rPr>
-                        <a:t>Answer correctness</a:t>
-                      </a:r>
-                    </a:p>
-                  </a:txBody>
-                  <a:tcPr marL="91440" marR="91440" marT="36576" marB="36576" anchor="ctr">
-                    <a:lnL w="12700" cap="flat" cmpd="sng" algn="ctr">
-                      <a:solidFill>
-                        <a:schemeClr val="tx1"/>
-                      </a:solidFill>
-                      <a:prstDash val="solid"/>
-                    </a:lnL>
-                    <a:lnR w="12700" cap="flat" cmpd="sng" algn="ctr">
-                      <a:solidFill>
-                        <a:schemeClr val="tx1"/>
-                      </a:solidFill>
-                      <a:prstDash val="solid"/>
-                    </a:lnR>
-                    <a:lnT w="12700" cap="flat" cmpd="sng" algn="ctr">
-                      <a:solidFill>
-                        <a:schemeClr val="tx1"/>
-                      </a:solidFill>
-                      <a:prstDash val="solid"/>
-                    </a:lnT>
-                    <a:lnB w="12700" cap="flat" cmpd="sng" algn="ctr">
-                      <a:solidFill>
-                        <a:schemeClr val="tx1"/>
-                      </a:solidFill>
-                      <a:prstDash val="solid"/>
-                    </a:lnB>
-                    <a:solidFill>
-                      <a:schemeClr val="bg1"/>
-                    </a:solidFill>
-                  </a:tcPr>
-                </a:tc>
-                <a:tc>
-                  <a:txBody>
-                    <a:bodyPr wrap="square"/>
-                    <a:lstStyle/>
-                    <a:p>
-                      <a:r>
-                        <a:rPr sz="1400" b="0" i="0">
-                          <a:solidFill>
-                            <a:schemeClr val="tx1"/>
-                          </a:solidFill>
-                        </a:rPr>
-                        <a:t>50 benchmark questions with expected answers</a:t>
-                      </a:r>
-                    </a:p>
-                  </a:txBody>
-                  <a:tcPr marL="91440" marR="91440" marT="36576" marB="36576" anchor="ctr">
-                    <a:lnL w="12700" cap="flat" cmpd="sng" algn="ctr">
-                      <a:solidFill>
-                        <a:schemeClr val="tx1"/>
-                      </a:solidFill>
-                      <a:prstDash val="solid"/>
-                    </a:lnL>
-                    <a:lnR w="12700" cap="flat" cmpd="sng" algn="ctr">
-                      <a:solidFill>
-                        <a:schemeClr val="tx1"/>
-                      </a:solidFill>
-                      <a:prstDash val="solid"/>
-                    </a:lnR>
-                    <a:lnT w="12700" cap="flat" cmpd="sng" algn="ctr">
-                      <a:solidFill>
-                        <a:schemeClr val="tx1"/>
-                      </a:solidFill>
-                      <a:prstDash val="solid"/>
-                    </a:lnT>
-                    <a:lnB w="12700" cap="flat" cmpd="sng" algn="ctr">
-                      <a:solidFill>
-                        <a:schemeClr val="tx1"/>
-                      </a:solidFill>
-                      <a:prstDash val="solid"/>
-                    </a:lnB>
-                    <a:solidFill>
-                      <a:schemeClr val="bg1"/>
-                    </a:solidFill>
-                  </a:tcPr>
-                </a:tc>
-                <a:tc>
-                  <a:txBody>
-                    <a:bodyPr wrap="square"/>
-                    <a:lstStyle/>
-                    <a:p>
-                      <a:r>
-                        <a:rPr sz="1400" b="0" i="0">
-                          <a:solidFill>
-                            <a:schemeClr val="tx1"/>
-                          </a:solidFill>
-                        </a:rPr>
-                        <a:t>Compared across 4 configurations</a:t>
-                      </a:r>
-                    </a:p>
-                  </a:txBody>
-                  <a:tcPr marL="91440" marR="91440" marT="36576" marB="36576" anchor="ctr">
-                    <a:lnL w="12700" cap="flat" cmpd="sng" algn="ctr">
-                      <a:solidFill>
-                        <a:schemeClr val="tx1"/>
-                      </a:solidFill>
-                      <a:prstDash val="solid"/>
-                    </a:lnL>
-                    <a:lnR w="12700" cap="flat" cmpd="sng" algn="ctr">
-                      <a:solidFill>
-                        <a:schemeClr val="tx1"/>
-                      </a:solidFill>
-                      <a:prstDash val="solid"/>
-                    </a:lnR>
-                    <a:lnT w="12700" cap="flat" cmpd="sng" algn="ctr">
-                      <a:solidFill>
-                        <a:schemeClr val="tx1"/>
-                      </a:solidFill>
-                      <a:prstDash val="solid"/>
-                    </a:lnT>
-                    <a:lnB w="12700" cap="flat" cmpd="sng" algn="ctr">
-                      <a:solidFill>
-                        <a:schemeClr val="tx1"/>
-                      </a:solidFill>
-                      <a:prstDash val="solid"/>
-                    </a:lnB>
-                    <a:solidFill>
-                      <a:schemeClr val="bg1"/>
-                    </a:solidFill>
-                  </a:tcPr>
-                </a:tc>
-              </a:tr>
-              <a:tr h="457200">
-                <a:tc>
-                  <a:txBody>
-                    <a:bodyPr wrap="square"/>
-                    <a:lstStyle/>
-                    <a:p>
-                      <a:r>
-                        <a:rPr sz="1400" b="0" i="0">
-                          <a:solidFill>
-                            <a:schemeClr val="tx1"/>
-                          </a:solidFill>
-                        </a:rPr>
-                        <a:t>Citation correctness</a:t>
-                      </a:r>
-                    </a:p>
-                  </a:txBody>
-                  <a:tcPr marL="91440" marR="91440" marT="36576" marB="36576" anchor="ctr">
-                    <a:lnL w="12700" cap="flat" cmpd="sng" algn="ctr">
-                      <a:solidFill>
-                        <a:schemeClr val="tx1"/>
-                      </a:solidFill>
-                      <a:prstDash val="solid"/>
-                    </a:lnL>
-                    <a:lnR w="12700" cap="flat" cmpd="sng" algn="ctr">
-                      <a:solidFill>
-                        <a:schemeClr val="tx1"/>
-                      </a:solidFill>
-                      <a:prstDash val="solid"/>
-                    </a:lnR>
-                    <a:lnT w="12700" cap="flat" cmpd="sng" algn="ctr">
-                      <a:solidFill>
-                        <a:schemeClr val="tx1"/>
-                      </a:solidFill>
-                      <a:prstDash val="solid"/>
-                    </a:lnT>
-                    <a:lnB w="12700" cap="flat" cmpd="sng" algn="ctr">
-                      <a:solidFill>
-                        <a:schemeClr val="tx1"/>
-                      </a:solidFill>
-                      <a:prstDash val="solid"/>
-                    </a:lnB>
-                    <a:solidFill>
-                      <a:schemeClr val="bg1"/>
-                    </a:solidFill>
-                  </a:tcPr>
-                </a:tc>
-                <a:tc>
-                  <a:txBody>
-                    <a:bodyPr wrap="square"/>
-                    <a:lstStyle/>
-                    <a:p>
-                      <a:r>
-                        <a:rPr sz="1400" b="0" i="0">
-                          <a:solidFill>
-                            <a:schemeClr val="tx1"/>
-                          </a:solidFill>
-                        </a:rPr>
-                        <a:t>Cited chunk actually contains the supporting text</a:t>
-                      </a:r>
-                    </a:p>
-                  </a:txBody>
-                  <a:tcPr marL="91440" marR="91440" marT="36576" marB="36576" anchor="ctr">
-                    <a:lnL w="12700" cap="flat" cmpd="sng" algn="ctr">
-                      <a:solidFill>
-                        <a:schemeClr val="tx1"/>
-                      </a:solidFill>
-                      <a:prstDash val="solid"/>
-                    </a:lnL>
-                    <a:lnR w="12700" cap="flat" cmpd="sng" algn="ctr">
-                      <a:solidFill>
-                        <a:schemeClr val="tx1"/>
-                      </a:solidFill>
-                      <a:prstDash val="solid"/>
-                    </a:lnR>
-                    <a:lnT w="12700" cap="flat" cmpd="sng" algn="ctr">
-                      <a:solidFill>
-                        <a:schemeClr val="tx1"/>
-                      </a:solidFill>
-                      <a:prstDash val="solid"/>
-                    </a:lnT>
-                    <a:lnB w="12700" cap="flat" cmpd="sng" algn="ctr">
-                      <a:solidFill>
-                        <a:schemeClr val="tx1"/>
-                      </a:solidFill>
-                      <a:prstDash val="solid"/>
-                    </a:lnB>
-                    <a:solidFill>
-                      <a:schemeClr val="bg1"/>
-                    </a:solidFill>
-                  </a:tcPr>
-                </a:tc>
-                <a:tc>
-                  <a:txBody>
-                    <a:bodyPr wrap="square"/>
-                    <a:lstStyle/>
-                    <a:p>
-                      <a:r>
-                        <a:rPr sz="1400" b="0" i="0">
-                          <a:solidFill>
-                            <a:schemeClr val="tx1"/>
-                          </a:solidFill>
-                        </a:rPr>
-                        <a:t>Every citation verifiable</a:t>
-                      </a:r>
-                    </a:p>
-                  </a:txBody>
-                  <a:tcPr marL="91440" marR="91440" marT="36576" marB="36576" anchor="ctr">
-                    <a:lnL w="12700" cap="flat" cmpd="sng" algn="ctr">
-                      <a:solidFill>
-                        <a:schemeClr val="tx1"/>
-                      </a:solidFill>
-                      <a:prstDash val="solid"/>
-                    </a:lnL>
-                    <a:lnR w="12700" cap="flat" cmpd="sng" algn="ctr">
-                      <a:solidFill>
-                        <a:schemeClr val="tx1"/>
-                      </a:solidFill>
-                      <a:prstDash val="solid"/>
-                    </a:lnR>
-                    <a:lnT w="12700" cap="flat" cmpd="sng" algn="ctr">
-                      <a:solidFill>
-                        <a:schemeClr val="tx1"/>
-                      </a:solidFill>
-                      <a:prstDash val="solid"/>
-                    </a:lnT>
-                    <a:lnB w="12700" cap="flat" cmpd="sng" algn="ctr">
-                      <a:solidFill>
-                        <a:schemeClr val="tx1"/>
-                      </a:solidFill>
-                      <a:prstDash val="solid"/>
-                    </a:lnB>
-                    <a:solidFill>
-                      <a:schemeClr val="bg1"/>
-                    </a:solidFill>
-                  </a:tcPr>
-                </a:tc>
-              </a:tr>
-              <a:tr h="457200">
-                <a:tc>
-                  <a:txBody>
-                    <a:bodyPr wrap="square"/>
-                    <a:lstStyle/>
-                    <a:p>
-                      <a:r>
-                        <a:rPr sz="1400" b="0" i="0">
-                          <a:solidFill>
-                            <a:schemeClr val="tx1"/>
-                          </a:solidFill>
-                        </a:rPr>
-                        <a:t>Tool-selection accuracy</a:t>
-                      </a:r>
-                    </a:p>
-                  </a:txBody>
-                  <a:tcPr marL="91440" marR="91440" marT="36576" marB="36576" anchor="ctr">
-                    <a:lnL w="12700" cap="flat" cmpd="sng" algn="ctr">
-                      <a:solidFill>
-                        <a:schemeClr val="tx1"/>
-                      </a:solidFill>
-                      <a:prstDash val="solid"/>
-                    </a:lnL>
-                    <a:lnR w="12700" cap="flat" cmpd="sng" algn="ctr">
-                      <a:solidFill>
-                        <a:schemeClr val="tx1"/>
-                      </a:solidFill>
-                      <a:prstDash val="solid"/>
-                    </a:lnR>
-                    <a:lnT w="12700" cap="flat" cmpd="sng" algn="ctr">
-                      <a:solidFill>
-                        <a:schemeClr val="tx1"/>
-                      </a:solidFill>
-                      <a:prstDash val="solid"/>
-                    </a:lnT>
-                    <a:lnB w="12700" cap="flat" cmpd="sng" algn="ctr">
-                      <a:solidFill>
-                        <a:schemeClr val="tx1"/>
-                      </a:solidFill>
-                      <a:prstDash val="solid"/>
-                    </a:lnB>
-                    <a:solidFill>
-                      <a:schemeClr val="bg1"/>
-                    </a:solidFill>
-                  </a:tcPr>
-                </a:tc>
-                <a:tc>
-                  <a:txBody>
-                    <a:bodyPr wrap="square"/>
-                    <a:lstStyle/>
-                    <a:p>
-                      <a:r>
-                        <a:rPr sz="1400" b="0" i="0">
-                          <a:solidFill>
-                            <a:schemeClr val="tx1"/>
-                          </a:solidFill>
-                        </a:rPr>
-                        <a:t>Expected vs. actual tool calls per question</a:t>
-                      </a:r>
-                    </a:p>
-                  </a:txBody>
-                  <a:tcPr marL="91440" marR="91440" marT="36576" marB="36576" anchor="ctr">
-                    <a:lnL w="12700" cap="flat" cmpd="sng" algn="ctr">
-                      <a:solidFill>
-                        <a:schemeClr val="tx1"/>
-                      </a:solidFill>
-                      <a:prstDash val="solid"/>
-                    </a:lnL>
-                    <a:lnR w="12700" cap="flat" cmpd="sng" algn="ctr">
-                      <a:solidFill>
-                        <a:schemeClr val="tx1"/>
-                      </a:solidFill>
-                      <a:prstDash val="solid"/>
-                    </a:lnR>
-                    <a:lnT w="12700" cap="flat" cmpd="sng" algn="ctr">
-                      <a:solidFill>
-                        <a:schemeClr val="tx1"/>
-                      </a:solidFill>
-                      <a:prstDash val="solid"/>
-                    </a:lnT>
-                    <a:lnB w="12700" cap="flat" cmpd="sng" algn="ctr">
-                      <a:solidFill>
-                        <a:schemeClr val="tx1"/>
-                      </a:solidFill>
-                      <a:prstDash val="solid"/>
-                    </a:lnB>
-                    <a:solidFill>
-                      <a:schemeClr val="bg1"/>
-                    </a:solidFill>
-                  </a:tcPr>
-                </a:tc>
-                <a:tc>
-                  <a:txBody>
-                    <a:bodyPr wrap="square"/>
-                    <a:lstStyle/>
-                    <a:p>
-                      <a:r>
-                        <a:rPr sz="1400" b="0" i="0">
-                          <a:solidFill>
-                            <a:schemeClr val="tx1"/>
-                          </a:solidFill>
-                        </a:rPr>
-                        <a:t>Hosted vs. local model</a:t>
-                      </a:r>
-                    </a:p>
-                  </a:txBody>
-                  <a:tcPr marL="91440" marR="91440" marT="36576" marB="36576" anchor="ctr">
-                    <a:lnL w="12700" cap="flat" cmpd="sng" algn="ctr">
-                      <a:solidFill>
-                        <a:schemeClr val="tx1"/>
-                      </a:solidFill>
-                      <a:prstDash val="solid"/>
-                    </a:lnL>
-                    <a:lnR w="12700" cap="flat" cmpd="sng" algn="ctr">
-                      <a:solidFill>
-                        <a:schemeClr val="tx1"/>
-                      </a:solidFill>
-                      <a:prstDash val="solid"/>
-                    </a:lnR>
-                    <a:lnT w="12700" cap="flat" cmpd="sng" algn="ctr">
-                      <a:solidFill>
-                        <a:schemeClr val="tx1"/>
-                      </a:solidFill>
-                      <a:prstDash val="solid"/>
-                    </a:lnT>
-                    <a:lnB w="12700" cap="flat" cmpd="sng" algn="ctr">
-                      <a:solidFill>
-                        <a:schemeClr val="tx1"/>
-                      </a:solidFill>
-                      <a:prstDash val="solid"/>
-                    </a:lnB>
-                    <a:solidFill>
-                      <a:schemeClr val="bg1"/>
-                    </a:solidFill>
-                  </a:tcPr>
-                </a:tc>
-              </a:tr>
-              <a:tr h="457200">
-                <a:tc>
-                  <a:txBody>
-                    <a:bodyPr wrap="square"/>
-                    <a:lstStyle/>
-                    <a:p>
-                      <a:r>
-                        <a:rPr sz="1400" b="0" i="0">
-                          <a:solidFill>
-                            <a:schemeClr val="tx1"/>
-                          </a:solidFill>
-                        </a:rPr>
-                        <a:t>Cross-student leakage</a:t>
-                      </a:r>
-                    </a:p>
-                  </a:txBody>
-                  <a:tcPr marL="91440" marR="91440" marT="36576" marB="36576" anchor="ctr">
-                    <a:lnL w="12700" cap="flat" cmpd="sng" algn="ctr">
-                      <a:solidFill>
-                        <a:schemeClr val="tx1"/>
-                      </a:solidFill>
-                      <a:prstDash val="solid"/>
-                    </a:lnL>
-                    <a:lnR w="12700" cap="flat" cmpd="sng" algn="ctr">
-                      <a:solidFill>
-                        <a:schemeClr val="tx1"/>
-                      </a:solidFill>
-                      <a:prstDash val="solid"/>
-                    </a:lnR>
-                    <a:lnT w="12700" cap="flat" cmpd="sng" algn="ctr">
-                      <a:solidFill>
-                        <a:schemeClr val="tx1"/>
-                      </a:solidFill>
-                      <a:prstDash val="solid"/>
-                    </a:lnT>
-                    <a:lnB w="12700" cap="flat" cmpd="sng" algn="ctr">
-                      <a:solidFill>
-                        <a:schemeClr val="tx1"/>
-                      </a:solidFill>
-                      <a:prstDash val="solid"/>
-                    </a:lnB>
-                    <a:solidFill>
-                      <a:schemeClr val="bg1"/>
-                    </a:solidFill>
-                  </a:tcPr>
-                </a:tc>
-                <a:tc>
-                  <a:txBody>
-                    <a:bodyPr wrap="square"/>
-                    <a:lstStyle/>
-                    <a:p>
-                      <a:r>
-                        <a:rPr sz="1400" b="0" i="0">
-                          <a:solidFill>
-                            <a:schemeClr val="tx1"/>
-                          </a:solidFill>
-                        </a:rPr>
-                        <a:t>Scripted attack suite (IDs, prompts, PDFs)</a:t>
-                      </a:r>
-                    </a:p>
-                  </a:txBody>
-                  <a:tcPr marL="91440" marR="91440" marT="36576" marB="36576" anchor="ctr">
-                    <a:lnL w="12700" cap="flat" cmpd="sng" algn="ctr">
-                      <a:solidFill>
-                        <a:schemeClr val="tx1"/>
-                      </a:solidFill>
-                      <a:prstDash val="solid"/>
-                    </a:lnL>
-                    <a:lnR w="12700" cap="flat" cmpd="sng" algn="ctr">
-                      <a:solidFill>
-                        <a:schemeClr val="tx1"/>
-                      </a:solidFill>
-                      <a:prstDash val="solid"/>
-                    </a:lnR>
-                    <a:lnT w="12700" cap="flat" cmpd="sng" algn="ctr">
-                      <a:solidFill>
-                        <a:schemeClr val="tx1"/>
-                      </a:solidFill>
-                      <a:prstDash val="solid"/>
-                    </a:lnT>
-                    <a:lnB w="12700" cap="flat" cmpd="sng" algn="ctr">
-                      <a:solidFill>
-                        <a:schemeClr val="tx1"/>
-                      </a:solidFill>
-                      <a:prstDash val="solid"/>
-                    </a:lnB>
-                    <a:solidFill>
-                      <a:schemeClr val="bg1"/>
-                    </a:solidFill>
-                  </a:tcPr>
-                </a:tc>
-                <a:tc>
-                  <a:txBody>
-                    <a:bodyPr wrap="square"/>
-                    <a:lstStyle/>
-                    <a:p>
-                      <a:r>
-                        <a:rPr sz="1400" b="0" i="0">
-                          <a:solidFill>
-                            <a:schemeClr val="tx1"/>
-                          </a:solidFill>
-                        </a:rPr>
-                        <a:t>0 leaked records (NFR-S1)</a:t>
-                      </a:r>
-                    </a:p>
-                  </a:txBody>
-                  <a:tcPr marL="91440" marR="91440" marT="36576" marB="36576" anchor="ctr">
-                    <a:lnL w="12700" cap="flat" cmpd="sng" algn="ctr">
-                      <a:solidFill>
-                        <a:schemeClr val="tx1"/>
-                      </a:solidFill>
-                      <a:prstDash val="solid"/>
-                    </a:lnL>
-                    <a:lnR w="12700" cap="flat" cmpd="sng" algn="ctr">
-                      <a:solidFill>
-                        <a:schemeClr val="tx1"/>
-                      </a:solidFill>
-                      <a:prstDash val="solid"/>
-                    </a:lnR>
-                    <a:lnT w="12700" cap="flat" cmpd="sng" algn="ctr">
-                      <a:solidFill>
-                        <a:schemeClr val="tx1"/>
-                      </a:solidFill>
-                      <a:prstDash val="solid"/>
-                    </a:lnT>
-                    <a:lnB w="12700" cap="flat" cmpd="sng" algn="ctr">
-                      <a:solidFill>
-                        <a:schemeClr val="tx1"/>
-                      </a:solidFill>
-                      <a:prstDash val="solid"/>
-                    </a:lnB>
-                    <a:solidFill>
-                      <a:schemeClr val="bg1"/>
-                    </a:solidFill>
-                  </a:tcPr>
-                </a:tc>
-              </a:tr>
-              <a:tr h="457200">
-                <a:tc>
-                  <a:txBody>
-                    <a:bodyPr wrap="square"/>
-                    <a:lstStyle/>
-                    <a:p>
-                      <a:r>
-                        <a:rPr sz="1400" b="0" i="0">
-                          <a:solidFill>
-                            <a:schemeClr val="tx1"/>
-                          </a:solidFill>
-                        </a:rPr>
-                        <a:t>Chat latency</a:t>
-                      </a:r>
-                    </a:p>
-                  </a:txBody>
-                  <a:tcPr marL="91440" marR="91440" marT="36576" marB="36576" anchor="ctr">
-                    <a:lnL w="12700" cap="flat" cmpd="sng" algn="ctr">
-                      <a:solidFill>
-                        <a:schemeClr val="tx1"/>
-                      </a:solidFill>
-                      <a:prstDash val="solid"/>
-                    </a:lnL>
-                    <a:lnR w="12700" cap="flat" cmpd="sng" algn="ctr">
-                      <a:solidFill>
-                        <a:schemeClr val="tx1"/>
-                      </a:solidFill>
-                      <a:prstDash val="solid"/>
-                    </a:lnR>
-                    <a:lnT w="12700" cap="flat" cmpd="sng" algn="ctr">
-                      <a:solidFill>
-                        <a:schemeClr val="tx1"/>
-                      </a:solidFill>
-                      <a:prstDash val="solid"/>
-                    </a:lnT>
-                    <a:lnB w="12700" cap="flat" cmpd="sng" algn="ctr">
-                      <a:solidFill>
-                        <a:schemeClr val="tx1"/>
-                      </a:solidFill>
-                      <a:prstDash val="solid"/>
-                    </a:lnB>
-                    <a:solidFill>
-                      <a:schemeClr val="bg1"/>
-                    </a:solidFill>
-                  </a:tcPr>
-                </a:tc>
-                <a:tc>
-                  <a:txBody>
-                    <a:bodyPr wrap="square"/>
-                    <a:lstStyle/>
-                    <a:p>
-                      <a:r>
-                        <a:rPr sz="1400" b="0" i="0">
-                          <a:solidFill>
-                            <a:schemeClr val="tx1"/>
-                          </a:solidFill>
-                        </a:rPr>
-                        <a:t>Median end-to-end answer time</a:t>
-                      </a:r>
-                    </a:p>
-                  </a:txBody>
-                  <a:tcPr marL="91440" marR="91440" marT="36576" marB="36576" anchor="ctr">
-                    <a:lnL w="12700" cap="flat" cmpd="sng" algn="ctr">
-                      <a:solidFill>
-                        <a:schemeClr val="tx1"/>
-                      </a:solidFill>
-                      <a:prstDash val="solid"/>
-                    </a:lnL>
-                    <a:lnR w="12700" cap="flat" cmpd="sng" algn="ctr">
-                      <a:solidFill>
-                        <a:schemeClr val="tx1"/>
-                      </a:solidFill>
-                      <a:prstDash val="solid"/>
-                    </a:lnR>
-                    <a:lnT w="12700" cap="flat" cmpd="sng" algn="ctr">
-                      <a:solidFill>
-                        <a:schemeClr val="tx1"/>
-                      </a:solidFill>
-                      <a:prstDash val="solid"/>
-                    </a:lnT>
-                    <a:lnB w="12700" cap="flat" cmpd="sng" algn="ctr">
-                      <a:solidFill>
-                        <a:schemeClr val="tx1"/>
-                      </a:solidFill>
-                      <a:prstDash val="solid"/>
-                    </a:lnB>
-                    <a:solidFill>
-                      <a:schemeClr val="bg1"/>
-                    </a:solidFill>
-                  </a:tcPr>
-                </a:tc>
-                <a:tc>
-                  <a:txBody>
-                    <a:bodyPr wrap="square"/>
-                    <a:lstStyle/>
-                    <a:p>
-                      <a:r>
-                        <a:rPr sz="1400" b="0" i="0">
-                          <a:solidFill>
-                            <a:schemeClr val="tx1"/>
-                          </a:solidFill>
-                        </a:rPr>
-                        <a:t>&lt; 8 s (NFR-P4)</a:t>
-                      </a:r>
-                    </a:p>
-                  </a:txBody>
-                  <a:tcPr marL="91440" marR="91440" marT="36576" marB="36576" anchor="ctr">
-                    <a:lnL w="12700" cap="flat" cmpd="sng" algn="ctr">
-                      <a:solidFill>
-                        <a:schemeClr val="tx1"/>
-                      </a:solidFill>
-                      <a:prstDash val="solid"/>
-                    </a:lnL>
-                    <a:lnR w="12700" cap="flat" cmpd="sng" algn="ctr">
-                      <a:solidFill>
-                        <a:schemeClr val="tx1"/>
-                      </a:solidFill>
-                      <a:prstDash val="solid"/>
-                    </a:lnR>
-                    <a:lnT w="12700" cap="flat" cmpd="sng" algn="ctr">
-                      <a:solidFill>
-                        <a:schemeClr val="tx1"/>
-                      </a:solidFill>
-                      <a:prstDash val="solid"/>
-                    </a:lnT>
-                    <a:lnB w="12700" cap="flat" cmpd="sng" algn="ctr">
-                      <a:solidFill>
-                        <a:schemeClr val="tx1"/>
-                      </a:solidFill>
-                      <a:prstDash val="solid"/>
-                    </a:lnB>
-                    <a:solidFill>
-                      <a:schemeClr val="bg1"/>
-                    </a:solidFill>
-                  </a:tcPr>
-                </a:tc>
-              </a:tr>
-              <a:tr h="457200">
-                <a:tc>
-                  <a:txBody>
-                    <a:bodyPr wrap="square"/>
-                    <a:lstStyle/>
-                    <a:p>
-                      <a:r>
-                        <a:rPr sz="1400" b="0" i="0">
-                          <a:solidFill>
-                            <a:schemeClr val="tx1"/>
-                          </a:solidFill>
-                        </a:rPr>
-                        <a:t>Retrieval latency</a:t>
-                      </a:r>
-                    </a:p>
-                  </a:txBody>
-                  <a:tcPr marL="91440" marR="91440" marT="36576" marB="36576" anchor="ctr">
-                    <a:lnL w="12700" cap="flat" cmpd="sng" algn="ctr">
-                      <a:solidFill>
-                        <a:schemeClr val="tx1"/>
-                      </a:solidFill>
-                      <a:prstDash val="solid"/>
-                    </a:lnL>
-                    <a:lnR w="12700" cap="flat" cmpd="sng" algn="ctr">
-                      <a:solidFill>
-                        <a:schemeClr val="tx1"/>
-                      </a:solidFill>
-                      <a:prstDash val="solid"/>
-                    </a:lnR>
-                    <a:lnT w="12700" cap="flat" cmpd="sng" algn="ctr">
-                      <a:solidFill>
-                        <a:schemeClr val="tx1"/>
-                      </a:solidFill>
-                      <a:prstDash val="solid"/>
-                    </a:lnT>
-                    <a:lnB w="12700" cap="flat" cmpd="sng" algn="ctr">
-                      <a:solidFill>
-                        <a:schemeClr val="tx1"/>
-                      </a:solidFill>
-                      <a:prstDash val="solid"/>
-                    </a:lnB>
-                    <a:solidFill>
-                      <a:schemeClr val="bg1"/>
-                    </a:solidFill>
-                  </a:tcPr>
-                </a:tc>
-                <a:tc>
-                  <a:txBody>
-                    <a:bodyPr wrap="square"/>
-                    <a:lstStyle/>
-                    <a:p>
-                      <a:r>
-                        <a:rPr sz="1400" b="0" i="0">
-                          <a:solidFill>
-                            <a:schemeClr val="tx1"/>
-                          </a:solidFill>
-                        </a:rPr>
-                        <a:t>Hybrid search time per query</a:t>
-                      </a:r>
-                    </a:p>
-                  </a:txBody>
-                  <a:tcPr marL="91440" marR="91440" marT="36576" marB="36576" anchor="ctr">
-                    <a:lnL w="12700" cap="flat" cmpd="sng" algn="ctr">
-                      <a:solidFill>
-                        <a:schemeClr val="tx1"/>
-                      </a:solidFill>
-                      <a:prstDash val="solid"/>
-                    </a:lnL>
-                    <a:lnR w="12700" cap="flat" cmpd="sng" algn="ctr">
-                      <a:solidFill>
-                        <a:schemeClr val="tx1"/>
-                      </a:solidFill>
-                      <a:prstDash val="solid"/>
-                    </a:lnR>
-                    <a:lnT w="12700" cap="flat" cmpd="sng" algn="ctr">
-                      <a:solidFill>
-                        <a:schemeClr val="tx1"/>
-                      </a:solidFill>
-                      <a:prstDash val="solid"/>
-                    </a:lnT>
-                    <a:lnB w="12700" cap="flat" cmpd="sng" algn="ctr">
-                      <a:solidFill>
-                        <a:schemeClr val="tx1"/>
-                      </a:solidFill>
-                      <a:prstDash val="solid"/>
-                    </a:lnB>
-                    <a:solidFill>
-                      <a:schemeClr val="bg1"/>
-                    </a:solidFill>
-                  </a:tcPr>
-                </a:tc>
-                <a:tc>
-                  <a:txBody>
-                    <a:bodyPr wrap="square"/>
-                    <a:lstStyle/>
-                    <a:p>
-                      <a:r>
-                        <a:rPr sz="1400" b="0" i="0">
-                          <a:solidFill>
-                            <a:schemeClr val="tx1"/>
-                          </a:solidFill>
-                        </a:rPr>
-                        <a:t>&lt; 500 ms (NFR-P3)</a:t>
-                      </a:r>
-                    </a:p>
-                  </a:txBody>
-                  <a:tcPr marL="91440" marR="91440" marT="36576" marB="36576" anchor="ctr">
-                    <a:lnL w="12700" cap="flat" cmpd="sng" algn="ctr">
-                      <a:solidFill>
-                        <a:schemeClr val="tx1"/>
-                      </a:solidFill>
-                      <a:prstDash val="solid"/>
-                    </a:lnL>
-                    <a:lnR w="12700" cap="flat" cmpd="sng" algn="ctr">
-                      <a:solidFill>
-                        <a:schemeClr val="tx1"/>
-                      </a:solidFill>
-                      <a:prstDash val="solid"/>
-                    </a:lnR>
-                    <a:lnT w="12700" cap="flat" cmpd="sng" algn="ctr">
-                      <a:solidFill>
-                        <a:schemeClr val="tx1"/>
-                      </a:solidFill>
-                      <a:prstDash val="solid"/>
-                    </a:lnT>
-                    <a:lnB w="12700" cap="flat" cmpd="sng" algn="ctr">
-                      <a:solidFill>
-                        <a:schemeClr val="tx1"/>
-                      </a:solidFill>
-                      <a:prstDash val="solid"/>
-                    </a:lnB>
-                    <a:solidFill>
-                      <a:schemeClr val="bg1"/>
-                    </a:solidFill>
-                  </a:tcPr>
-                </a:tc>
-              </a:tr>
-            </a:tbl>
-          </a:graphicData>
-        </a:graphic>
-      </p:graphicFrame>
-      <p:sp>
-        <p:nvSpPr>
-          <p:cNvPr id="4" name="Rectangle 3"/>
-          <p:cNvSpPr/>
-          <p:nvPr/>
-        </p:nvSpPr>
-        <p:spPr>
-          <a:xfrm>
-            <a:off x="384048" y="4526280"/>
-            <a:ext cx="11430000" cy="1737360"/>
-          </a:xfrm>
-          <a:prstGeom prst="rect">
-            <a:avLst/>
-          </a:prstGeom>
-          <a:solidFill>
-            <a:schemeClr val="bg1"/>
-          </a:solidFill>
-          <a:ln w="15875">
-            <a:solidFill>
-              <a:schemeClr val="accent2"/>
-            </a:solidFill>
-          </a:ln>
-          <a:effectLst/>
-        </p:spPr>
-        <p:style>
-          <a:lnRef idx="1">
-            <a:schemeClr val="accent1"/>
-          </a:lnRef>
-          <a:fillRef idx="3">
-            <a:schemeClr val="accent1"/>
-          </a:fillRef>
-          <a:effectRef idx="2">
-            <a:schemeClr val="accent1"/>
-          </a:effectRef>
-          <a:fontRef idx="minor">
-            <a:schemeClr val="lt1"/>
-          </a:fontRef>
-        </p:style>
-        <p:txBody>
-          <a:bodyPr rtlCol="0" anchor="ctr"/>
-          <a:lstStyle/>
-          <a:p/>
-        </p:txBody>
-      </p:sp>
-      <p:sp>
-        <p:nvSpPr>
-          <p:cNvPr id="5" name="TextBox 4"/>
-          <p:cNvSpPr txBox="1"/>
-          <p:nvPr/>
-        </p:nvSpPr>
-        <p:spPr>
-          <a:xfrm>
-            <a:off x="594360" y="4617720"/>
-            <a:ext cx="10972800" cy="411480"/>
-          </a:xfrm>
-          <a:prstGeom prst="rect">
-            <a:avLst/>
-          </a:prstGeom>
-          <a:noFill/>
-        </p:spPr>
-        <p:txBody>
-          <a:bodyPr wrap="square">
-            <a:spAutoFit/>
-          </a:bodyPr>
-          <a:lstStyle/>
-          <a:p>
-            <a:r>
-              <a:rPr sz="2200" b="1" i="0">
-                <a:solidFill>
-                  <a:schemeClr val="accent2"/>
-                </a:solidFill>
-              </a:rPr>
-              <a:t>Baselines</a:t>
-            </a:r>
-          </a:p>
-        </p:txBody>
-      </p:sp>
-      <p:sp>
-        <p:nvSpPr>
-          <p:cNvPr id="6" name="TextBox 5"/>
-          <p:cNvSpPr txBox="1"/>
-          <p:nvPr/>
-        </p:nvSpPr>
-        <p:spPr>
-          <a:xfrm>
-            <a:off x="594360" y="5074920"/>
-            <a:ext cx="10972800" cy="1097280"/>
-          </a:xfrm>
-          <a:prstGeom prst="rect">
-            <a:avLst/>
-          </a:prstGeom>
-          <a:noFill/>
-        </p:spPr>
-        <p:txBody>
-          <a:bodyPr wrap="square">
-            <a:spAutoFit/>
-          </a:bodyPr>
-          <a:lstStyle/>
-          <a:p>
-            <a:r>
-              <a:rPr sz="2000" b="0" i="0">
-                <a:solidFill>
-                  <a:schemeClr val="tx1"/>
-                </a:solidFill>
-              </a:rPr>
-              <a:t>1. Plain LLM with no university context   ·   2. RAG only (documents, no records)   ·   3. Database tools only (no documents)   ·   4. Full CampusGPT. Results will be reported after implementation; none are claimed yet.</a:t>
-            </a:r>
-          </a:p>
-        </p:txBody>
-      </p:sp>
-    </p:spTree>
-  </p:cSld>
-  <p:clrMapOvr>
-    <a:masterClrMapping/>
-  </p:clrMapOvr>
-</p:sld>
-</file>
-
-<file path=ppt/slides/slide16.xml><?xml version="1.0" encoding="utf-8"?>
-<p:sld xmlns:a="http://schemas.openxmlformats.org/drawingml/2006/main" xmlns:p="http://schemas.openxmlformats.org/presentationml/2006/main" xmlns:r="http://schemas.openxmlformats.org/officeDocument/2006/relationships">
-  <p:cSld>
-    <p:spTree>
-      <p:nvGrpSpPr>
-        <p:cNvPr id="1" name=""/>
-        <p:cNvGrpSpPr/>
-        <p:nvPr/>
-      </p:nvGrpSpPr>
-      <p:grpSpPr/>
-      <p:sp>
-        <p:nvSpPr>
-          <p:cNvPr id="2" name="Title 1"/>
-          <p:cNvSpPr>
-            <a:spLocks noGrp="1"/>
-          </p:cNvSpPr>
-          <p:nvPr>
-            <p:ph type="title" idx="102"/>
-          </p:nvPr>
-        </p:nvSpPr>
-        <p:spPr/>
-        <p:txBody>
-          <a:bodyPr/>
-          <a:lstStyle/>
-          <a:p>
-            <a:r>
-              <a:rPr sz="3200" b="1" i="0">
-                <a:solidFill>
-                  <a:schemeClr val="tx1"/>
-                </a:solidFill>
-              </a:rPr>
-              <a:t>14. SWOT Analysis</a:t>
+              <a:t>13. SWOT Analysis</a:t>
             </a:r>
           </a:p>
         </p:txBody>
@@ -4999,7 +3860,7 @@
 </p:sld>
 </file>
 
-<file path=ppt/slides/slide17.xml><?xml version="1.0" encoding="utf-8"?>
+<file path=ppt/slides/slide16.xml><?xml version="1.0" encoding="utf-8"?>
 <p:sld xmlns:a="http://schemas.openxmlformats.org/drawingml/2006/main" xmlns:p="http://schemas.openxmlformats.org/presentationml/2006/main" xmlns:r="http://schemas.openxmlformats.org/officeDocument/2006/relationships">
   <p:cSld>
     <p:spTree>
@@ -5030,7 +3891,7 @@
                   <a:schemeClr val="tx1"/>
                 </a:solidFill>
               </a:rPr>
-              <a:t>15. Project Schedule</a:t>
+              <a:t>14. Project Schedule</a:t>
             </a:r>
           </a:p>
         </p:txBody>
@@ -5174,7 +4035,7 @@
 </p:sld>
 </file>
 
-<file path=ppt/slides/slide18.xml><?xml version="1.0" encoding="utf-8"?>
+<file path=ppt/slides/slide17.xml><?xml version="1.0" encoding="utf-8"?>
 <p:sld xmlns:a="http://schemas.openxmlformats.org/drawingml/2006/main" xmlns:p="http://schemas.openxmlformats.org/presentationml/2006/main" xmlns:r="http://schemas.openxmlformats.org/officeDocument/2006/relationships">
   <p:cSld>
     <p:spTree>
@@ -5205,7 +4066,7 @@
                   <a:schemeClr val="tx1"/>
                 </a:solidFill>
               </a:rPr>
-              <a:t>16. Limitations, Future Work &amp; Conclusion</a:t>
+              <a:t>15. Limitations, Future Work &amp; Conclusion</a:t>
             </a:r>
           </a:p>
         </p:txBody>
@@ -5672,7 +4533,7 @@
 </p:sld>
 </file>
 
-<file path=ppt/slides/slide19.xml><?xml version="1.0" encoding="utf-8"?>
+<file path=ppt/slides/slide18.xml><?xml version="1.0" encoding="utf-8"?>
 <p:sld xmlns:a="http://schemas.openxmlformats.org/drawingml/2006/main" xmlns:p="http://schemas.openxmlformats.org/presentationml/2006/main" xmlns:r="http://schemas.openxmlformats.org/officeDocument/2006/relationships">
   <p:cSld>
     <p:spTree>
@@ -5703,7 +4564,7 @@
                   <a:schemeClr val="tx1"/>
                 </a:solidFill>
               </a:rPr>
-              <a:t>17. References</a:t>
+              <a:t>16. References</a:t>
             </a:r>
           </a:p>
         </p:txBody>
@@ -6066,21 +4927,6 @@
               <a:t>8. Data Flow Diagram</a:t>
             </a:r>
           </a:p>
-          <a:p>
-            <a:pPr>
-              <a:spcAft>
-                <a:spcPts val="800"/>
-              </a:spcAft>
-            </a:pPr>
-            <a:r>
-              <a:rPr sz="1700" b="0" i="0">
-                <a:solidFill>
-                  <a:schemeClr val="tx1"/>
-                </a:solidFill>
-              </a:rPr>
-              <a:t>9. Inter-Process Communication</a:t>
-            </a:r>
-          </a:p>
         </p:txBody>
       </p:sp>
       <p:sp>
@@ -6116,6 +4962,21 @@
                   <a:schemeClr val="tx1"/>
                 </a:solidFill>
               </a:rPr>
+              <a:t>9. Inter-Process Communication</a:t>
+            </a:r>
+          </a:p>
+          <a:p>
+            <a:pPr>
+              <a:spcAft>
+                <a:spcPts val="800"/>
+              </a:spcAft>
+            </a:pPr>
+            <a:r>
+              <a:rPr sz="1700" b="0" i="0">
+                <a:solidFill>
+                  <a:schemeClr val="tx1"/>
+                </a:solidFill>
+              </a:rPr>
               <a:t>10. Database Design</a:t>
             </a:r>
           </a:p>
@@ -6161,7 +5022,7 @@
                   <a:schemeClr val="tx1"/>
                 </a:solidFill>
               </a:rPr>
-              <a:t>13. Evaluation Plan</a:t>
+              <a:t>13. SWOT Analysis</a:t>
             </a:r>
           </a:p>
           <a:p>
@@ -6176,7 +5037,7 @@
                   <a:schemeClr val="tx1"/>
                 </a:solidFill>
               </a:rPr>
-              <a:t>14. SWOT Analysis</a:t>
+              <a:t>14. Project Schedule</a:t>
             </a:r>
           </a:p>
           <a:p>
@@ -6191,7 +5052,7 @@
                   <a:schemeClr val="tx1"/>
                 </a:solidFill>
               </a:rPr>
-              <a:t>15. Project Schedule</a:t>
+              <a:t>15. Limitations, Future Work &amp; Conclusion</a:t>
             </a:r>
           </a:p>
           <a:p>
@@ -6206,22 +5067,7 @@
                   <a:schemeClr val="tx1"/>
                 </a:solidFill>
               </a:rPr>
-              <a:t>16. Limitations, Future Work &amp; Conclusion</a:t>
-            </a:r>
-          </a:p>
-          <a:p>
-            <a:pPr>
-              <a:spcAft>
-                <a:spcPts val="800"/>
-              </a:spcAft>
-            </a:pPr>
-            <a:r>
-              <a:rPr sz="1700" b="0" i="0">
-                <a:solidFill>
-                  <a:schemeClr val="tx1"/>
-                </a:solidFill>
-              </a:rPr>
-              <a:t>17. References</a:t>
+              <a:t>16. References</a:t>
             </a:r>
           </a:p>
         </p:txBody>

</xml_diff>

<commit_message>
Database schema, migrations and synthetic data generator
- SQLAlchemy models for all 23 tables (academic records, accounts, documents,
  chat and audit), matching the ER diagrams
- Alembic migration 0001 with attendance_summary and invoice_balances views and
  a trigger keeping submission marks within the assignment maximum
- Deterministic generator (NumPy + Faker en_IN): 5,000 students, ~825k
  attendance records, assessments, fees, notices; four demo accounts with
  fixed profiles; loaded with COPY in one transaction in ~20 s
- 12 SQL validation checks and 20 pytest tests on a separate test database
- scripts/db.sh and Makefile for the local PostgreSQL cluster
- Docs and slides updated with the generated table sizes (23 tables)

Co-Authored-By: Claude Opus 5.5 <noreply@anthropic.com>
</commit_message>
<xml_diff>
--- a/docs/slides/CampusGPT_Major_Project.pptx
+++ b/docs/slides/CampusGPT_Major_Project.pptx
@@ -1889,7 +1889,7 @@
         <p:spPr>
           <a:xfrm>
             <a:off x="7269480" y="1097280"/>
-            <a:ext cx="4572000" cy="2810040"/>
+            <a:ext cx="4572000" cy="2819856"/>
           </a:xfrm>
           <a:prstGeom prst="rect">
             <a:avLst/>
@@ -1931,7 +1931,7 @@
                   <a:schemeClr val="tx1"/>
                 </a:solidFill>
               </a:rPr>
-              <a:t>21 tables</a:t>
+              <a:t>23 tables</a:t>
             </a:r>
             <a:r>
               <a:rPr sz="1500" b="0" i="0">
@@ -8283,7 +8283,7 @@
                   <a:schemeClr val="tx1"/>
                 </a:solidFill>
               </a:rPr>
-              <a:t>: no real university data; every row is labelled is_synthetic.</a:t>
+              <a:t>: no real university data; students, notices and documents are labelled is_synthetic.</a:t>
             </a:r>
           </a:p>
           <a:p>
@@ -8308,7 +8308,7 @@
                   <a:schemeClr val="tx1"/>
                 </a:solidFill>
               </a:rPr>
-              <a:t>: 5,000 students, 150 faculty, 180 courses and about 1.35 million attendance records.</a:t>
+              <a:t>: 5,000 students, 148 faculty, 190 courses and about 825,000 attendance records, generated and loaded in about 20 seconds.</a:t>
             </a:r>
           </a:p>
           <a:p>
@@ -8511,7 +8511,7 @@
                             <a:schemeClr val="tx1"/>
                           </a:solidFill>
                         </a:rPr>
-                        <a:t>Planned rows</a:t>
+                        <a:t>Rows</a:t>
                       </a:r>
                     </a:p>
                   </a:txBody>
@@ -8785,7 +8785,7 @@
                             <a:schemeClr val="tx1"/>
                           </a:solidFill>
                         </a:rPr>
-                        <a:t>30,000</a:t>
+                        <a:t>25,000</a:t>
                       </a:r>
                     </a:p>
                   </a:txBody>
@@ -8922,7 +8922,7 @@
                             <a:schemeClr val="tx1"/>
                           </a:solidFill>
                         </a:rPr>
-                        <a:t>18,000</a:t>
+                        <a:t>15,338</a:t>
                       </a:r>
                     </a:p>
                   </a:txBody>
@@ -9059,7 +9059,7 @@
                             <a:schemeClr val="tx1"/>
                           </a:solidFill>
                         </a:rPr>
-                        <a:t>1,350,000</a:t>
+                        <a:t>824,636</a:t>
                       </a:r>
                     </a:p>
                   </a:txBody>
@@ -9196,7 +9196,7 @@
                             <a:schemeClr val="tx1"/>
                           </a:solidFill>
                         </a:rPr>
-                        <a:t>1,600</a:t>
+                        <a:t>1,860</a:t>
                       </a:r>
                     </a:p>
                   </a:txBody>
@@ -9333,7 +9333,7 @@
                             <a:schemeClr val="tx1"/>
                           </a:solidFill>
                         </a:rPr>
-                        <a:t>110,000</a:t>
+                        <a:t>65,378</a:t>
                       </a:r>
                     </a:p>
                   </a:txBody>
@@ -9470,7 +9470,7 @@
                             <a:schemeClr val="tx1"/>
                           </a:solidFill>
                         </a:rPr>
-                        <a:t>800</a:t>
+                        <a:t>1,395</a:t>
                       </a:r>
                     </a:p>
                   </a:txBody>

</xml_diff>